<commit_message>
links-26: Short Run corrections from the fourth audit
- The manager deck said Short Run's weekly hours sit "inside" today's range; its lightest
  week (24h 30m) is below today's lightest (25h 10m). The notes now give both ranges.
- The short-version tile's sub-line now reads "up to 6 · today 7", as Even Keel's does,
  instead of today's worst case.
- README: five of the six exact skeletons did not take the times, not four; and 43h 40m is
  not a hard limit — no rule caps a week, only the 35-hour average — it was Second Nature's
  heaviest week used as the searches' ceiling.

deck-check: 306 rows agree. Pack rebuilt.

Co-Authored-By: Claude Fable 5.1 <noreply@anthropic.com>
Claude-Session: https://claude.ai/code/session_01MrfcTRinN39zgr6tpkue66
</commit_message>
<xml_diff>
--- a/docs/links-26/presentations/Short-Run-for-managers.pptx
+++ b/docs/links-26/presentations/Short-Run-for-managers.pptx
@@ -1282,7 +1282,7 @@
           <a:p>
             <a:r>
               <a:rPr lang="en-US" dirty="0"/>
-              <a:t>Working weeks average exactly 35 hours Monday to Saturday — 44,100 minutes across the 21 working weeks — so no overtime is needed to balance the Monday-to-Saturday week. Individual weeks range from 24h 30m to 42h 30m, inside today’s 25h 10m to 43h 50m; only the average is the contract, as today. Five cover weeks keep about the same share of the link as today’s four in 20 (one week in 5.2, against one in 5). Sunday is not contracted, so the ten Sunday duties are worked as rest-day overtime, exactly as today’s eight are. The two extra Sunday overtime duties a week come from the Sunday staffing of ten, confirmed verbally — any link that meets the rules needs them. The 26-week link, its five cover weeks and the ceiling of 219 contracted days a year were agreed on 1 October 2026; Short Run gives 218.6.</a:t>
+              <a:t>Working weeks average exactly 35 hours Monday to Saturday — 44,100 minutes across the 21 working weeks — so no overtime is needed to balance the Monday-to-Saturday week. Individual weeks range from 24h 30m to 42h 30m — today’s run from 25h 10m to 43h 50m, so the heaviest is lighter than today’s heaviest and the lightest a little lighter than today’s lightest; only the average is the contract, as today. Five cover weeks keep about the same share of the link as today’s four in 20 (one week in 5.2, against one in 5). Sunday is not contracted, so the ten Sunday duties are worked as rest-day overtime, exactly as today’s eight are. The two extra Sunday overtime duties a week come from the Sunday staffing of ten, confirmed verbally — any link that meets the rules needs them. The 26-week link, its five cover weeks and the ceiling of 219 contracted days a year were agreed on 1 October 2026; Short Run gives 218.6.</a:t>
             </a:r>
             <a:endParaRPr lang="en-US" dirty="0"/>
           </a:p>
@@ -1458,7 +1458,7 @@
           <a:p>
             <a:r>
               <a:rPr lang="en-US" dirty="0"/>
-              <a:t>This is the case in one slide. It meets every December staffing rule and keeps the shift times people already work wherever that cost little — nine of its fifteen are worked today, and none on a Saturday is new. Nobody works more than five days in a row on the fixed rota, where today it is seven; a cover week placed badly can make it six, never more. Every working week is all earlies or all lates, and 18 of the 21 keep one shift time Monday to Friday, where today it is seven weeks in 16. Its seven full weekends off in 26 weeks are never more than five weeks apart, which is as close as the five cover weeks allow; today it is four in 20, up to seven weeks apart. The honest cost is late finishes, and it is the smallest one possible: the December staffing needs three to the close every day, and only those three finish after 23:00, so finishes at 23:00 or later go from about 39 to 42 a year each. Its heaviest week is 42h 30m, inside today’s range (today’s heaviest is 43h 50m). Every closing shift is 30 to 45 minutes shorter. Six shift times are new.</a:t>
+              <a:t>This is the case in one slide. It meets every December staffing rule and keeps the shift times people already work wherever that cost little — nine of its fifteen are worked today, and none on a Saturday is new. Nobody works more than five days in a row on the fixed rota, where today it is seven; a cover week placed badly can make it six, never more. Every working week is all earlies or all lates, and 18 of the 21 keep one shift time Monday to Friday, where today it is seven weeks in 16. Its seven full weekends off in 26 weeks are never more than five weeks apart, which is as close as the five cover weeks allow; today it is four in 20, up to seven weeks apart. The honest cost is late finishes, and it is the smallest one possible: the December staffing needs three to the close every day, and only those three finish after 23:00, so finishes at 23:00 or later go from about 39 to 42 a year each. Its heaviest week is 42h 30m, against today’s 43h 50m. Every closing shift is 30 to 45 minutes shorter. Six shift times are new.</a:t>
             </a:r>
             <a:endParaRPr lang="en-US" dirty="0"/>
           </a:p>
@@ -1546,7 +1546,7 @@
           <a:p>
             <a:r>
               <a:rPr lang="en-US" dirty="0"/>
-              <a:t>Days at work stay at 219 a year (218.6 exactly; Monday to Saturday; Sunday is overtime), under the ceiling agreed on 1 October 2026. Late finishes average about three more a year each, all of them from the December staffing — three to the close every day, where today’s weekdays have two — so no link meeting the same rules on 26 weeks could have fewer. Full weekends off are seven in 26 and never more than five weeks apart; nobody works more than five days in a row on the fixed rota; no week mixes earlies and lates, and 18 of the 21 working weeks keep one shift time. Weekly hours run from 24h 30m to 42h 30m, inside today’s 25h 10m to 43h 50m; only the average is the contract. The average shift is about two minutes longer.</a:t>
+              <a:t>Days at work stay at 219 a year (218.6 exactly; Monday to Saturday; Sunday is overtime), under the ceiling agreed on 1 October 2026. Late finishes average about three more a year each, all of them from the December staffing — three to the close every day, where today’s weekdays have two — so no link meeting the same rules on 26 weeks could have fewer. Full weekends off are seven in 26 and never more than five weeks apart; nobody works more than five days in a row on the fixed rota; no week mixes earlies and lates, and 18 of the 21 working weeks keep one shift time. Weekly hours run from 24h 30m to 42h 30m (today 25h 10m to 43h 50m); only the average is the contract. The average shift is about two minutes longer.</a:t>
             </a:r>
             <a:endParaRPr lang="en-US" dirty="0"/>
           </a:p>

</xml_diff>